<commit_message>
Add a slide detailing audio clip treatment differences
Add a third slide to the producer guide PPTX detailing the differences in audio treatment for short vs. long audio clips, updating the PPTX generation script and associated metadata.

Replit-Commit-Author: Agent
Replit-Commit-Session-Id: f15ee2f5-87b5-43b5-8b3e-b0801834337d
Replit-Commit-Checkpoint-Type: full_checkpoint
Replit-Commit-Event-Id: 6c410b3a-5f74-4e5d-ac0a-8b24d77d686e
Replit-Commit-Screenshot-Url: https://storage.googleapis.com/screenshot-production-us-central1/5427b858-8852-4aed-954b-cd80d9fa4b6b/f15ee2f5-87b5-43b5-8b3e-b0801834337d/kY3Hvyf
Replit-Helium-Checkpoint-Created: true
</commit_message>
<xml_diff>
--- a/exports/guia-productor.pptx
+++ b/exports/guia-productor.pptx
@@ -7,9 +7,10 @@
   <p:sldIdLst>
     <p:sldId id="256" r:id="rId2"/>
     <p:sldId id="257" r:id="rId3"/>
+    <p:sldId id="258" r:id="rId4"/>
   </p:sldIdLst>
   <p:notesMasterIdLst>
-    <p:notesMasterId r:id="rId4"/>
+    <p:notesMasterId r:id="rId5"/>
   </p:notesMasterIdLst>
   <p:sldSz cx="12192000" cy="6858000"/>
   <p:notesSz cx="6858000" cy="12192000"/>
@@ -615,6 +616,94 @@
             <a:fld id="{F7021451-1387-4CA6-816F-3879F97B5CBC}" type="slidenum">
               <a:rPr lang="en-US"/>
               <a:t>2</a:t>
+            </a:fld>
+            <a:endParaRPr lang="en-US"/>
+          </a:p>
+        </p:txBody>
+      </p:sp>
+    </p:spTree>
+    <p:extLst>
+      <p:ext uri="{BB962C8B-B14F-4D97-AF65-F5344CB8AC3E}">
+        <p14:creationId xmlns:p14="http://schemas.microsoft.com/office/powerpoint/2010/main" val="1024086991"/>
+      </p:ext>
+    </p:extLst>
+  </p:cSld>
+  <p:clrMapOvr>
+    <a:masterClrMapping/>
+  </p:clrMapOvr>
+</p:notes>
+</file>
+
+<file path=ppt/notesSlides/notesSlide3.xml><?xml version="1.0" encoding="utf-8"?>
+<p:notes xmlns:a="http://schemas.openxmlformats.org/drawingml/2006/main" xmlns:r="http://schemas.openxmlformats.org/officeDocument/2006/relationships" xmlns:p="http://schemas.openxmlformats.org/presentationml/2006/main">
+  <p:cSld>
+    <p:spTree>
+      <p:nvGrpSpPr>
+        <p:cNvPr id="1" name=""/>
+        <p:cNvGrpSpPr/>
+        <p:nvPr/>
+      </p:nvGrpSpPr>
+      <p:grpSpPr>
+        <a:xfrm>
+          <a:off x="0" y="0"/>
+          <a:ext cx="0" cy="0"/>
+          <a:chOff x="0" y="0"/>
+          <a:chExt cx="0" cy="0"/>
+        </a:xfrm>
+      </p:grpSpPr>
+      <p:sp>
+        <p:nvSpPr>
+          <p:cNvPr id="2" name="Slide Image Placeholder 1"/>
+          <p:cNvSpPr>
+            <a:spLocks noGrp="1" noRot="1" noChangeAspect="1"/>
+          </p:cNvSpPr>
+          <p:nvPr>
+            <p:ph type="sldImg"/>
+          </p:nvPr>
+        </p:nvSpPr>
+        <p:spPr/>
+      </p:sp>
+      <p:sp>
+        <p:nvSpPr>
+          <p:cNvPr id="3" name="Notes Placeholder 2"/>
+          <p:cNvSpPr>
+            <a:spLocks noGrp="1"/>
+          </p:cNvSpPr>
+          <p:nvPr>
+            <p:ph type="body" idx="1"/>
+          </p:nvPr>
+        </p:nvSpPr>
+        <p:spPr/>
+        <p:txBody>
+          <a:bodyPr/>
+          <a:lstStyle/>
+          <a:p>
+            <a:r>
+              <a:rPr lang="en-US" dirty="0"/>
+              <a:t/>
+            </a:r>
+            <a:endParaRPr lang="en-US" dirty="0"/>
+          </a:p>
+        </p:txBody>
+      </p:sp>
+      <p:sp>
+        <p:nvSpPr>
+          <p:cNvPr id="4" name="Slide Number Placeholder 3"/>
+          <p:cNvSpPr>
+            <a:spLocks noGrp="1"/>
+          </p:cNvSpPr>
+          <p:nvPr>
+            <p:ph type="sldNum" sz="quarter" idx="10"/>
+          </p:nvPr>
+        </p:nvSpPr>
+        <p:spPr/>
+        <p:txBody>
+          <a:bodyPr/>
+          <a:lstStyle/>
+          <a:p>
+            <a:fld id="{F7021451-1387-4CA6-816F-3879F97B5CBC}" type="slidenum">
+              <a:rPr lang="en-US"/>
+              <a:t>3</a:t>
             </a:fld>
             <a:endParaRPr lang="en-US"/>
           </a:p>
@@ -4822,6 +4911,1301 @@
 </p:sld>
 </file>
 
+<file path=ppt/slides/slide3.xml><?xml version="1.0" encoding="utf-8"?>
+<p:sld xmlns:a="http://schemas.openxmlformats.org/drawingml/2006/main" xmlns:r="http://schemas.openxmlformats.org/officeDocument/2006/relationships" xmlns:p="http://schemas.openxmlformats.org/presentationml/2006/main">
+  <p:cSld name="Slide 3">
+    <p:bg>
+      <p:bgPr>
+        <a:solidFill>
+          <a:srgbClr val="1B060F"/>
+        </a:solidFill>
+      </p:bgPr>
+    </p:bg>
+    <p:spTree>
+      <p:nvGrpSpPr>
+        <p:cNvPr id="1" name=""/>
+        <p:cNvGrpSpPr/>
+        <p:nvPr/>
+      </p:nvGrpSpPr>
+      <p:grpSpPr>
+        <a:xfrm>
+          <a:off x="0" y="0"/>
+          <a:ext cx="0" cy="0"/>
+          <a:chOff x="0" y="0"/>
+          <a:chExt cx="0" cy="0"/>
+        </a:xfrm>
+      </p:grpSpPr>
+      <p:sp>
+        <p:nvSpPr>
+          <p:cNvPr id="2" name="Shape 0"/>
+          <p:cNvSpPr/>
+          <p:nvPr/>
+        </p:nvSpPr>
+        <p:spPr>
+          <a:xfrm>
+            <a:off x="0" y="0"/>
+            <a:ext cx="12192000" cy="64008"/>
+          </a:xfrm>
+          <a:prstGeom prst="rect">
+            <a:avLst/>
+          </a:prstGeom>
+          <a:solidFill>
+            <a:srgbClr val="D4AF37"/>
+          </a:solidFill>
+          <a:ln w="12700">
+            <a:solidFill>
+              <a:srgbClr val="D4AF37"/>
+            </a:solidFill>
+            <a:prstDash val="solid"/>
+          </a:ln>
+        </p:spPr>
+      </p:sp>
+      <p:sp>
+        <p:nvSpPr>
+          <p:cNvPr id="3" name="Shape 1"/>
+          <p:cNvSpPr/>
+          <p:nvPr/>
+        </p:nvSpPr>
+        <p:spPr>
+          <a:xfrm>
+            <a:off x="0" y="0"/>
+            <a:ext cx="36576" cy="6858000"/>
+          </a:xfrm>
+          <a:prstGeom prst="rect">
+            <a:avLst/>
+          </a:prstGeom>
+          <a:solidFill>
+            <a:srgbClr val="4A0C0C"/>
+          </a:solidFill>
+          <a:ln w="12700">
+            <a:solidFill>
+              <a:srgbClr val="4A0C0C"/>
+            </a:solidFill>
+            <a:prstDash val="solid"/>
+          </a:ln>
+        </p:spPr>
+      </p:sp>
+      <p:sp>
+        <p:nvSpPr>
+          <p:cNvPr id="4" name="Text 2"/>
+          <p:cNvSpPr/>
+          <p:nvPr/>
+        </p:nvSpPr>
+        <p:spPr>
+          <a:xfrm>
+            <a:off x="274320" y="182880"/>
+            <a:ext cx="7315200" cy="640080"/>
+          </a:xfrm>
+          <a:prstGeom prst="rect">
+            <a:avLst/>
+          </a:prstGeom>
+          <a:noFill/>
+          <a:ln/>
+        </p:spPr>
+        <p:txBody>
+          <a:bodyPr wrap="square" rtlCol="0" anchor="ctr"/>
+          <a:lstStyle/>
+          <a:p>
+            <a:pPr indent="0" marL="0">
+              <a:buNone/>
+            </a:pPr>
+            <a:r>
+              <a:rPr lang="en-US" sz="2800" b="1" dirty="0">
+                <a:solidFill>
+                  <a:srgbClr val="D4AF37"/>
+                </a:solidFill>
+                <a:latin typeface="Georgia" pitchFamily="34" charset="0"/>
+                <a:ea typeface="Georgia" pitchFamily="34" charset="-122"/>
+                <a:cs typeface="Georgia" pitchFamily="34" charset="-120"/>
+              </a:rPr>
+              <a:t>Guía para el Productor</a:t>
+            </a:r>
+            <a:endParaRPr lang="en-US" sz="2800" dirty="0"/>
+          </a:p>
+        </p:txBody>
+      </p:sp>
+      <p:sp>
+        <p:nvSpPr>
+          <p:cNvPr id="5" name="Text 3"/>
+          <p:cNvSpPr/>
+          <p:nvPr/>
+        </p:nvSpPr>
+        <p:spPr>
+          <a:xfrm>
+            <a:off x="274320" y="777240"/>
+            <a:ext cx="7315200" cy="365760"/>
+          </a:xfrm>
+          <a:prstGeom prst="rect">
+            <a:avLst/>
+          </a:prstGeom>
+          <a:noFill/>
+          <a:ln/>
+        </p:spPr>
+        <p:txBody>
+          <a:bodyPr wrap="square" rtlCol="0" anchor="ctr"/>
+          <a:lstStyle/>
+          <a:p>
+            <a:pPr indent="0" marL="0">
+              <a:buNone/>
+            </a:pPr>
+            <a:r>
+              <a:rPr lang="en-US" sz="1300" i="1" dirty="0">
+                <a:solidFill>
+                  <a:srgbClr val="B89B96"/>
+                </a:solidFill>
+                <a:latin typeface="Calibri" pitchFamily="34" charset="0"/>
+                <a:ea typeface="Calibri" pitchFamily="34" charset="-122"/>
+                <a:cs typeface="Calibri" pitchFamily="34" charset="-120"/>
+              </a:rPr>
+              <a:t>Parte 3 — Clips cortos vs Clips largos</a:t>
+            </a:r>
+            <a:endParaRPr lang="en-US" sz="1300" dirty="0"/>
+          </a:p>
+        </p:txBody>
+      </p:sp>
+      <p:sp>
+        <p:nvSpPr>
+          <p:cNvPr id="6" name="Shape 4"/>
+          <p:cNvSpPr/>
+          <p:nvPr/>
+        </p:nvSpPr>
+        <p:spPr>
+          <a:xfrm>
+            <a:off x="274320" y="1097280"/>
+            <a:ext cx="11612880" cy="0"/>
+          </a:xfrm>
+          <a:prstGeom prst="line">
+            <a:avLst/>
+          </a:prstGeom>
+          <a:noFill/>
+          <a:ln w="19050">
+            <a:solidFill>
+              <a:srgbClr val="3D0E16"/>
+            </a:solidFill>
+            <a:prstDash val="solid"/>
+          </a:ln>
+        </p:spPr>
+      </p:sp>
+      <p:sp>
+        <p:nvSpPr>
+          <p:cNvPr id="7" name="Shape 5"/>
+          <p:cNvSpPr/>
+          <p:nvPr/>
+        </p:nvSpPr>
+        <p:spPr>
+          <a:xfrm>
+            <a:off x="274320" y="1234440"/>
+            <a:ext cx="5440680" cy="420624"/>
+          </a:xfrm>
+          <a:prstGeom prst="rect">
+            <a:avLst/>
+          </a:prstGeom>
+          <a:solidFill>
+            <a:srgbClr val="4A0C0C"/>
+          </a:solidFill>
+          <a:ln w="12700">
+            <a:solidFill>
+              <a:srgbClr val="3D0E16"/>
+            </a:solidFill>
+            <a:prstDash val="solid"/>
+          </a:ln>
+        </p:spPr>
+      </p:sp>
+      <p:sp>
+        <p:nvSpPr>
+          <p:cNvPr id="8" name="Text 6"/>
+          <p:cNvSpPr/>
+          <p:nvPr/>
+        </p:nvSpPr>
+        <p:spPr>
+          <a:xfrm>
+            <a:off x="274320" y="1234440"/>
+            <a:ext cx="5440680" cy="420624"/>
+          </a:xfrm>
+          <a:prstGeom prst="rect">
+            <a:avLst/>
+          </a:prstGeom>
+          <a:noFill/>
+          <a:ln/>
+        </p:spPr>
+        <p:txBody>
+          <a:bodyPr wrap="square" rtlCol="0" anchor="ctr"/>
+          <a:lstStyle/>
+          <a:p>
+            <a:pPr algn="ctr" indent="0" marL="0">
+              <a:buNone/>
+            </a:pPr>
+            <a:r>
+              <a:rPr lang="en-US" sz="1400" b="1" dirty="0">
+                <a:solidFill>
+                  <a:srgbClr val="D4AF37"/>
+                </a:solidFill>
+                <a:latin typeface="Georgia" pitchFamily="34" charset="0"/>
+                <a:ea typeface="Georgia" pitchFamily="34" charset="-122"/>
+                <a:cs typeface="Georgia" pitchFamily="34" charset="-120"/>
+              </a:rPr>
+              <a:t>Clips cortos  (30–40 s)</a:t>
+            </a:r>
+            <a:endParaRPr lang="en-US" sz="1400" dirty="0"/>
+          </a:p>
+        </p:txBody>
+      </p:sp>
+      <p:sp>
+        <p:nvSpPr>
+          <p:cNvPr id="9" name="Text 7"/>
+          <p:cNvSpPr/>
+          <p:nvPr/>
+        </p:nvSpPr>
+        <p:spPr>
+          <a:xfrm>
+            <a:off x="274320" y="1719072"/>
+            <a:ext cx="5440680" cy="274320"/>
+          </a:xfrm>
+          <a:prstGeom prst="rect">
+            <a:avLst/>
+          </a:prstGeom>
+          <a:noFill/>
+          <a:ln/>
+        </p:spPr>
+        <p:txBody>
+          <a:bodyPr wrap="square" rtlCol="0" anchor="ctr"/>
+          <a:lstStyle/>
+          <a:p>
+            <a:pPr algn="ctr" indent="0" marL="0">
+              <a:buNone/>
+            </a:pPr>
+            <a:r>
+              <a:rPr lang="en-US" sz="1000" i="1" dirty="0">
+                <a:solidFill>
+                  <a:srgbClr val="B89B96"/>
+                </a:solidFill>
+                <a:latin typeface="Calibri" pitchFamily="34" charset="0"/>
+                <a:ea typeface="Calibri" pitchFamily="34" charset="-122"/>
+                <a:cs typeface="Calibri" pitchFamily="34" charset="-120"/>
+              </a:rPr>
+              <a:t>Bloques individuales del mezclador (SOUND_MAP)</a:t>
+            </a:r>
+            <a:endParaRPr lang="en-US" sz="1000" dirty="0"/>
+          </a:p>
+        </p:txBody>
+      </p:sp>
+      <p:sp>
+        <p:nvSpPr>
+          <p:cNvPr id="10" name="Text 8"/>
+          <p:cNvSpPr/>
+          <p:nvPr/>
+        </p:nvSpPr>
+        <p:spPr>
+          <a:xfrm>
+            <a:off x="320040" y="2084832"/>
+            <a:ext cx="1828800" cy="274320"/>
+          </a:xfrm>
+          <a:prstGeom prst="rect">
+            <a:avLst/>
+          </a:prstGeom>
+          <a:noFill/>
+          <a:ln/>
+        </p:spPr>
+        <p:txBody>
+          <a:bodyPr wrap="square" rtlCol="0" anchor="ctr"/>
+          <a:lstStyle/>
+          <a:p>
+            <a:pPr indent="0" marL="0">
+              <a:buNone/>
+            </a:pPr>
+            <a:r>
+              <a:rPr lang="en-US" sz="1000" b="1" dirty="0">
+                <a:solidFill>
+                  <a:srgbClr val="E9C46A"/>
+                </a:solidFill>
+                <a:latin typeface="Calibri" pitchFamily="34" charset="0"/>
+                <a:ea typeface="Calibri" pitchFamily="34" charset="-122"/>
+                <a:cs typeface="Calibri" pitchFamily="34" charset="-120"/>
+              </a:rPr>
+              <a:t>Loop seamless</a:t>
+            </a:r>
+            <a:endParaRPr lang="en-US" sz="1000" dirty="0"/>
+          </a:p>
+        </p:txBody>
+      </p:sp>
+      <p:sp>
+        <p:nvSpPr>
+          <p:cNvPr id="11" name="Text 9"/>
+          <p:cNvSpPr/>
+          <p:nvPr/>
+        </p:nvSpPr>
+        <p:spPr>
+          <a:xfrm>
+            <a:off x="320040" y="2322576"/>
+            <a:ext cx="5257800" cy="329184"/>
+          </a:xfrm>
+          <a:prstGeom prst="rect">
+            <a:avLst/>
+          </a:prstGeom>
+          <a:noFill/>
+          <a:ln/>
+        </p:spPr>
+        <p:txBody>
+          <a:bodyPr wrap="square" rtlCol="0" anchor="ctr"/>
+          <a:lstStyle/>
+          <a:p>
+            <a:pPr indent="0" marL="0">
+              <a:buNone/>
+            </a:pPr>
+            <a:r>
+              <a:rPr lang="en-US" sz="950" dirty="0">
+                <a:solidFill>
+                  <a:srgbClr val="F4DAD5"/>
+                </a:solidFill>
+                <a:latin typeface="Calibri" pitchFamily="34" charset="0"/>
+                <a:ea typeface="Calibri" pitchFamily="34" charset="-122"/>
+                <a:cs typeface="Calibri" pitchFamily="34" charset="-120"/>
+              </a:rPr>
+              <a:t>Crítico — se escucha el punto de unión decenas de veces por sesión</a:t>
+            </a:r>
+            <a:endParaRPr lang="en-US" sz="950" dirty="0"/>
+          </a:p>
+        </p:txBody>
+      </p:sp>
+      <p:sp>
+        <p:nvSpPr>
+          <p:cNvPr id="12" name="Text 10"/>
+          <p:cNvSpPr/>
+          <p:nvPr/>
+        </p:nvSpPr>
+        <p:spPr>
+          <a:xfrm>
+            <a:off x="320040" y="2743200"/>
+            <a:ext cx="1828800" cy="274320"/>
+          </a:xfrm>
+          <a:prstGeom prst="rect">
+            <a:avLst/>
+          </a:prstGeom>
+          <a:noFill/>
+          <a:ln/>
+        </p:spPr>
+        <p:txBody>
+          <a:bodyPr wrap="square" rtlCol="0" anchor="ctr"/>
+          <a:lstStyle/>
+          <a:p>
+            <a:pPr indent="0" marL="0">
+              <a:buNone/>
+            </a:pPr>
+            <a:r>
+              <a:rPr lang="en-US" sz="1000" b="1" dirty="0">
+                <a:solidFill>
+                  <a:srgbClr val="E9C46A"/>
+                </a:solidFill>
+                <a:latin typeface="Calibri" pitchFamily="34" charset="0"/>
+                <a:ea typeface="Calibri" pitchFamily="34" charset="-122"/>
+                <a:cs typeface="Calibri" pitchFamily="34" charset="-120"/>
+              </a:rPr>
+              <a:t>Fade in/out en el archivo</a:t>
+            </a:r>
+            <a:endParaRPr lang="en-US" sz="1000" dirty="0"/>
+          </a:p>
+        </p:txBody>
+      </p:sp>
+      <p:sp>
+        <p:nvSpPr>
+          <p:cNvPr id="13" name="Text 11"/>
+          <p:cNvSpPr/>
+          <p:nvPr/>
+        </p:nvSpPr>
+        <p:spPr>
+          <a:xfrm>
+            <a:off x="320040" y="2980944"/>
+            <a:ext cx="5257800" cy="329184"/>
+          </a:xfrm>
+          <a:prstGeom prst="rect">
+            <a:avLst/>
+          </a:prstGeom>
+          <a:noFill/>
+          <a:ln/>
+        </p:spPr>
+        <p:txBody>
+          <a:bodyPr wrap="square" rtlCol="0" anchor="ctr"/>
+          <a:lstStyle/>
+          <a:p>
+            <a:pPr indent="0" marL="0">
+              <a:buNone/>
+            </a:pPr>
+            <a:r>
+              <a:rPr lang="en-US" sz="950" dirty="0">
+                <a:solidFill>
+                  <a:srgbClr val="F4DAD5"/>
+                </a:solidFill>
+                <a:latin typeface="Calibri" pitchFamily="34" charset="0"/>
+                <a:ea typeface="Calibri" pitchFamily="34" charset="-122"/>
+                <a:cs typeface="Calibri" pitchFamily="34" charset="-120"/>
+              </a:rPr>
+              <a:t>No incluir — el app controla el volumen con el slider</a:t>
+            </a:r>
+            <a:endParaRPr lang="en-US" sz="950" dirty="0"/>
+          </a:p>
+        </p:txBody>
+      </p:sp>
+      <p:sp>
+        <p:nvSpPr>
+          <p:cNvPr id="14" name="Text 12"/>
+          <p:cNvSpPr/>
+          <p:nvPr/>
+        </p:nvSpPr>
+        <p:spPr>
+          <a:xfrm>
+            <a:off x="320040" y="3401568"/>
+            <a:ext cx="1828800" cy="274320"/>
+          </a:xfrm>
+          <a:prstGeom prst="rect">
+            <a:avLst/>
+          </a:prstGeom>
+          <a:noFill/>
+          <a:ln/>
+        </p:spPr>
+        <p:txBody>
+          <a:bodyPr wrap="square" rtlCol="0" anchor="ctr"/>
+          <a:lstStyle/>
+          <a:p>
+            <a:pPr indent="0" marL="0">
+              <a:buNone/>
+            </a:pPr>
+            <a:r>
+              <a:rPr lang="en-US" sz="1000" b="1" dirty="0">
+                <a:solidFill>
+                  <a:srgbClr val="E9C46A"/>
+                </a:solidFill>
+                <a:latin typeface="Calibri" pitchFamily="34" charset="0"/>
+                <a:ea typeface="Calibri" pitchFamily="34" charset="-122"/>
+                <a:cs typeface="Calibri" pitchFamily="34" charset="-120"/>
+              </a:rPr>
+              <a:t>Contenido</a:t>
+            </a:r>
+            <a:endParaRPr lang="en-US" sz="1000" dirty="0"/>
+          </a:p>
+        </p:txBody>
+      </p:sp>
+      <p:sp>
+        <p:nvSpPr>
+          <p:cNvPr id="15" name="Text 13"/>
+          <p:cNvSpPr/>
+          <p:nvPr/>
+        </p:nvSpPr>
+        <p:spPr>
+          <a:xfrm>
+            <a:off x="320040" y="3639312"/>
+            <a:ext cx="5257800" cy="329184"/>
+          </a:xfrm>
+          <a:prstGeom prst="rect">
+            <a:avLst/>
+          </a:prstGeom>
+          <a:noFill/>
+          <a:ln/>
+        </p:spPr>
+        <p:txBody>
+          <a:bodyPr wrap="square" rtlCol="0" anchor="ctr"/>
+          <a:lstStyle/>
+          <a:p>
+            <a:pPr indent="0" marL="0">
+              <a:buNone/>
+            </a:pPr>
+            <a:r>
+              <a:rPr lang="en-US" sz="950" dirty="0">
+                <a:solidFill>
+                  <a:srgbClr val="F4DAD5"/>
+                </a:solidFill>
+                <a:latin typeface="Calibri" pitchFamily="34" charset="0"/>
+                <a:ea typeface="Calibri" pitchFamily="34" charset="-122"/>
+                <a:cs typeface="Calibri" pitchFamily="34" charset="-120"/>
+              </a:rPr>
+              <a:t>Un solo sonido limpio (el cuenco, el pájaro, el agua). Sin mezcla interna</a:t>
+            </a:r>
+            <a:endParaRPr lang="en-US" sz="950" dirty="0"/>
+          </a:p>
+        </p:txBody>
+      </p:sp>
+      <p:sp>
+        <p:nvSpPr>
+          <p:cNvPr id="16" name="Text 14"/>
+          <p:cNvSpPr/>
+          <p:nvPr/>
+        </p:nvSpPr>
+        <p:spPr>
+          <a:xfrm>
+            <a:off x="320040" y="4059936"/>
+            <a:ext cx="1828800" cy="274320"/>
+          </a:xfrm>
+          <a:prstGeom prst="rect">
+            <a:avLst/>
+          </a:prstGeom>
+          <a:noFill/>
+          <a:ln/>
+        </p:spPr>
+        <p:txBody>
+          <a:bodyPr wrap="square" rtlCol="0" anchor="ctr"/>
+          <a:lstStyle/>
+          <a:p>
+            <a:pPr indent="0" marL="0">
+              <a:buNone/>
+            </a:pPr>
+            <a:r>
+              <a:rPr lang="en-US" sz="1000" b="1" dirty="0">
+                <a:solidFill>
+                  <a:srgbClr val="E9C46A"/>
+                </a:solidFill>
+                <a:latin typeface="Calibri" pitchFamily="34" charset="0"/>
+                <a:ea typeface="Calibri" pitchFamily="34" charset="-122"/>
+                <a:cs typeface="Calibri" pitchFamily="34" charset="-120"/>
+              </a:rPr>
+              <a:t>Dinámica</a:t>
+            </a:r>
+            <a:endParaRPr lang="en-US" sz="1000" dirty="0"/>
+          </a:p>
+        </p:txBody>
+      </p:sp>
+      <p:sp>
+        <p:nvSpPr>
+          <p:cNvPr id="17" name="Text 15"/>
+          <p:cNvSpPr/>
+          <p:nvPr/>
+        </p:nvSpPr>
+        <p:spPr>
+          <a:xfrm>
+            <a:off x="320040" y="4297680"/>
+            <a:ext cx="5257800" cy="329184"/>
+          </a:xfrm>
+          <a:prstGeom prst="rect">
+            <a:avLst/>
+          </a:prstGeom>
+          <a:noFill/>
+          <a:ln/>
+        </p:spPr>
+        <p:txBody>
+          <a:bodyPr wrap="square" rtlCol="0" anchor="ctr"/>
+          <a:lstStyle/>
+          <a:p>
+            <a:pPr indent="0" marL="0">
+              <a:buNone/>
+            </a:pPr>
+            <a:r>
+              <a:rPr lang="en-US" sz="950" dirty="0">
+                <a:solidFill>
+                  <a:srgbClr val="F4DAD5"/>
+                </a:solidFill>
+                <a:latin typeface="Calibri" pitchFamily="34" charset="0"/>
+                <a:ea typeface="Calibri" pitchFamily="34" charset="-122"/>
+                <a:cs typeface="Calibri" pitchFamily="34" charset="-120"/>
+              </a:rPr>
+              <a:t>Estable y sin variación — es un loop continuo, no una composición</a:t>
+            </a:r>
+            <a:endParaRPr lang="en-US" sz="950" dirty="0"/>
+          </a:p>
+        </p:txBody>
+      </p:sp>
+      <p:sp>
+        <p:nvSpPr>
+          <p:cNvPr id="18" name="Text 16"/>
+          <p:cNvSpPr/>
+          <p:nvPr/>
+        </p:nvSpPr>
+        <p:spPr>
+          <a:xfrm>
+            <a:off x="320040" y="4718304"/>
+            <a:ext cx="1828800" cy="274320"/>
+          </a:xfrm>
+          <a:prstGeom prst="rect">
+            <a:avLst/>
+          </a:prstGeom>
+          <a:noFill/>
+          <a:ln/>
+        </p:spPr>
+        <p:txBody>
+          <a:bodyPr wrap="square" rtlCol="0" anchor="ctr"/>
+          <a:lstStyle/>
+          <a:p>
+            <a:pPr indent="0" marL="0">
+              <a:buNone/>
+            </a:pPr>
+            <a:r>
+              <a:rPr lang="en-US" sz="1000" b="1" dirty="0">
+                <a:solidFill>
+                  <a:srgbClr val="E9C46A"/>
+                </a:solidFill>
+                <a:latin typeface="Calibri" pitchFamily="34" charset="0"/>
+                <a:ea typeface="Calibri" pitchFamily="34" charset="-122"/>
+                <a:cs typeface="Calibri" pitchFamily="34" charset="-120"/>
+              </a:rPr>
+              <a:t>EQ / Reverb</a:t>
+            </a:r>
+            <a:endParaRPr lang="en-US" sz="1000" dirty="0"/>
+          </a:p>
+        </p:txBody>
+      </p:sp>
+      <p:sp>
+        <p:nvSpPr>
+          <p:cNvPr id="19" name="Text 17"/>
+          <p:cNvSpPr/>
+          <p:nvPr/>
+        </p:nvSpPr>
+        <p:spPr>
+          <a:xfrm>
+            <a:off x="320040" y="4956048"/>
+            <a:ext cx="5257800" cy="329184"/>
+          </a:xfrm>
+          <a:prstGeom prst="rect">
+            <a:avLst/>
+          </a:prstGeom>
+          <a:noFill/>
+          <a:ln/>
+        </p:spPr>
+        <p:txBody>
+          <a:bodyPr wrap="square" rtlCol="0" anchor="ctr"/>
+          <a:lstStyle/>
+          <a:p>
+            <a:pPr indent="0" marL="0">
+              <a:buNone/>
+            </a:pPr>
+            <a:r>
+              <a:rPr lang="en-US" sz="950" dirty="0">
+                <a:solidFill>
+                  <a:srgbClr val="F4DAD5"/>
+                </a:solidFill>
+                <a:latin typeface="Calibri" pitchFamily="34" charset="0"/>
+                <a:ea typeface="Calibri" pitchFamily="34" charset="-122"/>
+                <a:cs typeface="Calibri" pitchFamily="34" charset="-120"/>
+              </a:rPr>
+              <a:t>Tratamiento individual del instrumento. Reverb que muera antes del loop</a:t>
+            </a:r>
+            <a:endParaRPr lang="en-US" sz="950" dirty="0"/>
+          </a:p>
+        </p:txBody>
+      </p:sp>
+      <p:sp>
+        <p:nvSpPr>
+          <p:cNvPr id="20" name="Shape 18"/>
+          <p:cNvSpPr/>
+          <p:nvPr/>
+        </p:nvSpPr>
+        <p:spPr>
+          <a:xfrm>
+            <a:off x="6099048" y="1234440"/>
+            <a:ext cx="0" cy="5303520"/>
+          </a:xfrm>
+          <a:prstGeom prst="line">
+            <a:avLst/>
+          </a:prstGeom>
+          <a:noFill/>
+          <a:ln w="12700">
+            <a:solidFill>
+              <a:srgbClr val="3D0E16"/>
+            </a:solidFill>
+            <a:prstDash val="solid"/>
+          </a:ln>
+        </p:spPr>
+      </p:sp>
+      <p:sp>
+        <p:nvSpPr>
+          <p:cNvPr id="21" name="Shape 19"/>
+          <p:cNvSpPr/>
+          <p:nvPr/>
+        </p:nvSpPr>
+        <p:spPr>
+          <a:xfrm>
+            <a:off x="6263640" y="1234440"/>
+            <a:ext cx="5577840" cy="420624"/>
+          </a:xfrm>
+          <a:prstGeom prst="rect">
+            <a:avLst/>
+          </a:prstGeom>
+          <a:solidFill>
+            <a:srgbClr val="4A0C0C"/>
+          </a:solidFill>
+          <a:ln w="12700">
+            <a:solidFill>
+              <a:srgbClr val="3D0E16"/>
+            </a:solidFill>
+            <a:prstDash val="solid"/>
+          </a:ln>
+        </p:spPr>
+      </p:sp>
+      <p:sp>
+        <p:nvSpPr>
+          <p:cNvPr id="22" name="Text 20"/>
+          <p:cNvSpPr/>
+          <p:nvPr/>
+        </p:nvSpPr>
+        <p:spPr>
+          <a:xfrm>
+            <a:off x="6263640" y="1234440"/>
+            <a:ext cx="5577840" cy="420624"/>
+          </a:xfrm>
+          <a:prstGeom prst="rect">
+            <a:avLst/>
+          </a:prstGeom>
+          <a:noFill/>
+          <a:ln/>
+        </p:spPr>
+        <p:txBody>
+          <a:bodyPr wrap="square" rtlCol="0" anchor="ctr"/>
+          <a:lstStyle/>
+          <a:p>
+            <a:pPr algn="ctr" indent="0" marL="0">
+              <a:buNone/>
+            </a:pPr>
+            <a:r>
+              <a:rPr lang="en-US" sz="1400" b="1" dirty="0">
+                <a:solidFill>
+                  <a:srgbClr val="D4AF37"/>
+                </a:solidFill>
+                <a:latin typeface="Georgia" pitchFamily="34" charset="0"/>
+                <a:ea typeface="Georgia" pitchFamily="34" charset="-122"/>
+                <a:cs typeface="Georgia" pitchFamily="34" charset="-120"/>
+              </a:rPr>
+              <a:t>Clips largos  (2–3 min)</a:t>
+            </a:r>
+            <a:endParaRPr lang="en-US" sz="1400" dirty="0"/>
+          </a:p>
+        </p:txBody>
+      </p:sp>
+      <p:sp>
+        <p:nvSpPr>
+          <p:cNvPr id="23" name="Text 21"/>
+          <p:cNvSpPr/>
+          <p:nvPr/>
+        </p:nvSpPr>
+        <p:spPr>
+          <a:xfrm>
+            <a:off x="6263640" y="1719072"/>
+            <a:ext cx="5577840" cy="274320"/>
+          </a:xfrm>
+          <a:prstGeom prst="rect">
+            <a:avLst/>
+          </a:prstGeom>
+          <a:noFill/>
+          <a:ln/>
+        </p:spPr>
+        <p:txBody>
+          <a:bodyPr wrap="square" rtlCol="0" anchor="ctr"/>
+          <a:lstStyle/>
+          <a:p>
+            <a:pPr algn="ctr" indent="0" marL="0">
+              <a:buNone/>
+            </a:pPr>
+            <a:r>
+              <a:rPr lang="en-US" sz="1000" i="1" dirty="0">
+                <a:solidFill>
+                  <a:srgbClr val="B89B96"/>
+                </a:solidFill>
+                <a:latin typeface="Calibri" pitchFamily="34" charset="0"/>
+                <a:ea typeface="Calibri" pitchFamily="34" charset="-122"/>
+                <a:cs typeface="Calibri" pitchFamily="34" charset="-120"/>
+              </a:rPr>
+              <a:t>Sesión completa para el reproductor inmersivo (AUDIO_MAP / AMBIENT_MAP)</a:t>
+            </a:r>
+            <a:endParaRPr lang="en-US" sz="1000" dirty="0"/>
+          </a:p>
+        </p:txBody>
+      </p:sp>
+      <p:sp>
+        <p:nvSpPr>
+          <p:cNvPr id="24" name="Text 22"/>
+          <p:cNvSpPr/>
+          <p:nvPr/>
+        </p:nvSpPr>
+        <p:spPr>
+          <a:xfrm>
+            <a:off x="6309360" y="2084832"/>
+            <a:ext cx="1920240" cy="274320"/>
+          </a:xfrm>
+          <a:prstGeom prst="rect">
+            <a:avLst/>
+          </a:prstGeom>
+          <a:noFill/>
+          <a:ln/>
+        </p:spPr>
+        <p:txBody>
+          <a:bodyPr wrap="square" rtlCol="0" anchor="ctr"/>
+          <a:lstStyle/>
+          <a:p>
+            <a:pPr indent="0" marL="0">
+              <a:buNone/>
+            </a:pPr>
+            <a:r>
+              <a:rPr lang="en-US" sz="1000" b="1" dirty="0">
+                <a:solidFill>
+                  <a:srgbClr val="E9C46A"/>
+                </a:solidFill>
+                <a:latin typeface="Calibri" pitchFamily="34" charset="0"/>
+                <a:ea typeface="Calibri" pitchFamily="34" charset="-122"/>
+                <a:cs typeface="Calibri" pitchFamily="34" charset="-120"/>
+              </a:rPr>
+              <a:t>Loop seamless</a:t>
+            </a:r>
+            <a:endParaRPr lang="en-US" sz="1000" dirty="0"/>
+          </a:p>
+        </p:txBody>
+      </p:sp>
+      <p:sp>
+        <p:nvSpPr>
+          <p:cNvPr id="25" name="Text 23"/>
+          <p:cNvSpPr/>
+          <p:nvPr/>
+        </p:nvSpPr>
+        <p:spPr>
+          <a:xfrm>
+            <a:off x="6309360" y="2322576"/>
+            <a:ext cx="5394960" cy="329184"/>
+          </a:xfrm>
+          <a:prstGeom prst="rect">
+            <a:avLst/>
+          </a:prstGeom>
+          <a:noFill/>
+          <a:ln/>
+        </p:spPr>
+        <p:txBody>
+          <a:bodyPr wrap="square" rtlCol="0" anchor="ctr"/>
+          <a:lstStyle/>
+          <a:p>
+            <a:pPr indent="0" marL="0">
+              <a:buNone/>
+            </a:pPr>
+            <a:r>
+              <a:rPr lang="en-US" sz="950" dirty="0">
+                <a:solidFill>
+                  <a:srgbClr val="F4DAD5"/>
+                </a:solidFill>
+                <a:latin typeface="Calibri" pitchFamily="34" charset="0"/>
+                <a:ea typeface="Calibri" pitchFamily="34" charset="-122"/>
+                <a:cs typeface="Calibri" pitchFamily="34" charset="-120"/>
+              </a:rPr>
+              <a:t>Necesario si la sesión está marcada como loop — con 2–3 min la repetición es mucho menos perceptible</a:t>
+            </a:r>
+            <a:endParaRPr lang="en-US" sz="950" dirty="0"/>
+          </a:p>
+        </p:txBody>
+      </p:sp>
+      <p:sp>
+        <p:nvSpPr>
+          <p:cNvPr id="26" name="Text 24"/>
+          <p:cNvSpPr/>
+          <p:nvPr/>
+        </p:nvSpPr>
+        <p:spPr>
+          <a:xfrm>
+            <a:off x="6309360" y="2743200"/>
+            <a:ext cx="1920240" cy="274320"/>
+          </a:xfrm>
+          <a:prstGeom prst="rect">
+            <a:avLst/>
+          </a:prstGeom>
+          <a:noFill/>
+          <a:ln/>
+        </p:spPr>
+        <p:txBody>
+          <a:bodyPr wrap="square" rtlCol="0" anchor="ctr"/>
+          <a:lstStyle/>
+          <a:p>
+            <a:pPr indent="0" marL="0">
+              <a:buNone/>
+            </a:pPr>
+            <a:r>
+              <a:rPr lang="en-US" sz="1000" b="1" dirty="0">
+                <a:solidFill>
+                  <a:srgbClr val="E9C46A"/>
+                </a:solidFill>
+                <a:latin typeface="Calibri" pitchFamily="34" charset="0"/>
+                <a:ea typeface="Calibri" pitchFamily="34" charset="-122"/>
+                <a:cs typeface="Calibri" pitchFamily="34" charset="-120"/>
+              </a:rPr>
+              <a:t>Fade in/out en el archivo</a:t>
+            </a:r>
+            <a:endParaRPr lang="en-US" sz="1000" dirty="0"/>
+          </a:p>
+        </p:txBody>
+      </p:sp>
+      <p:sp>
+        <p:nvSpPr>
+          <p:cNvPr id="27" name="Text 25"/>
+          <p:cNvSpPr/>
+          <p:nvPr/>
+        </p:nvSpPr>
+        <p:spPr>
+          <a:xfrm>
+            <a:off x="6309360" y="2980944"/>
+            <a:ext cx="5394960" cy="329184"/>
+          </a:xfrm>
+          <a:prstGeom prst="rect">
+            <a:avLst/>
+          </a:prstGeom>
+          <a:noFill/>
+          <a:ln/>
+        </p:spPr>
+        <p:txBody>
+          <a:bodyPr wrap="square" rtlCol="0" anchor="ctr"/>
+          <a:lstStyle/>
+          <a:p>
+            <a:pPr indent="0" marL="0">
+              <a:buNone/>
+            </a:pPr>
+            <a:r>
+              <a:rPr lang="en-US" sz="950" dirty="0">
+                <a:solidFill>
+                  <a:srgbClr val="F4DAD5"/>
+                </a:solidFill>
+                <a:latin typeface="Calibri" pitchFamily="34" charset="0"/>
+                <a:ea typeface="Calibri" pitchFamily="34" charset="-122"/>
+                <a:cs typeface="Calibri" pitchFamily="34" charset="-120"/>
+              </a:rPr>
+              <a:t>Sí, recomendable — arranque suave y cierre gradual forman parte de la experiencia</a:t>
+            </a:r>
+            <a:endParaRPr lang="en-US" sz="950" dirty="0"/>
+          </a:p>
+        </p:txBody>
+      </p:sp>
+      <p:sp>
+        <p:nvSpPr>
+          <p:cNvPr id="28" name="Text 26"/>
+          <p:cNvSpPr/>
+          <p:nvPr/>
+        </p:nvSpPr>
+        <p:spPr>
+          <a:xfrm>
+            <a:off x="6309360" y="3401568"/>
+            <a:ext cx="1920240" cy="274320"/>
+          </a:xfrm>
+          <a:prstGeom prst="rect">
+            <a:avLst/>
+          </a:prstGeom>
+          <a:noFill/>
+          <a:ln/>
+        </p:spPr>
+        <p:txBody>
+          <a:bodyPr wrap="square" rtlCol="0" anchor="ctr"/>
+          <a:lstStyle/>
+          <a:p>
+            <a:pPr indent="0" marL="0">
+              <a:buNone/>
+            </a:pPr>
+            <a:r>
+              <a:rPr lang="en-US" sz="1000" b="1" dirty="0">
+                <a:solidFill>
+                  <a:srgbClr val="E9C46A"/>
+                </a:solidFill>
+                <a:latin typeface="Calibri" pitchFamily="34" charset="0"/>
+                <a:ea typeface="Calibri" pitchFamily="34" charset="-122"/>
+                <a:cs typeface="Calibri" pitchFamily="34" charset="-120"/>
+              </a:rPr>
+              <a:t>Contenido</a:t>
+            </a:r>
+            <a:endParaRPr lang="en-US" sz="1000" dirty="0"/>
+          </a:p>
+        </p:txBody>
+      </p:sp>
+      <p:sp>
+        <p:nvSpPr>
+          <p:cNvPr id="29" name="Text 27"/>
+          <p:cNvSpPr/>
+          <p:nvPr/>
+        </p:nvSpPr>
+        <p:spPr>
+          <a:xfrm>
+            <a:off x="6309360" y="3639312"/>
+            <a:ext cx="5394960" cy="329184"/>
+          </a:xfrm>
+          <a:prstGeom prst="rect">
+            <a:avLst/>
+          </a:prstGeom>
+          <a:noFill/>
+          <a:ln/>
+        </p:spPr>
+        <p:txBody>
+          <a:bodyPr wrap="square" rtlCol="0" anchor="ctr"/>
+          <a:lstStyle/>
+          <a:p>
+            <a:pPr indent="0" marL="0">
+              <a:buNone/>
+            </a:pPr>
+            <a:r>
+              <a:rPr lang="en-US" sz="950" dirty="0">
+                <a:solidFill>
+                  <a:srgbClr val="F4DAD5"/>
+                </a:solidFill>
+                <a:latin typeface="Calibri" pitchFamily="34" charset="0"/>
+                <a:ea typeface="Calibri" pitchFamily="34" charset="-122"/>
+                <a:cs typeface="Calibri" pitchFamily="34" charset="-120"/>
+              </a:rPr>
+              <a:t>Mezcla interna: cuencos + pajaritos + agua equilibrados en niveles por el productor antes de exportar</a:t>
+            </a:r>
+            <a:endParaRPr lang="en-US" sz="950" dirty="0"/>
+          </a:p>
+        </p:txBody>
+      </p:sp>
+      <p:sp>
+        <p:nvSpPr>
+          <p:cNvPr id="30" name="Text 28"/>
+          <p:cNvSpPr/>
+          <p:nvPr/>
+        </p:nvSpPr>
+        <p:spPr>
+          <a:xfrm>
+            <a:off x="6309360" y="4059936"/>
+            <a:ext cx="1920240" cy="274320"/>
+          </a:xfrm>
+          <a:prstGeom prst="rect">
+            <a:avLst/>
+          </a:prstGeom>
+          <a:noFill/>
+          <a:ln/>
+        </p:spPr>
+        <p:txBody>
+          <a:bodyPr wrap="square" rtlCol="0" anchor="ctr"/>
+          <a:lstStyle/>
+          <a:p>
+            <a:pPr indent="0" marL="0">
+              <a:buNone/>
+            </a:pPr>
+            <a:r>
+              <a:rPr lang="en-US" sz="1000" b="1" dirty="0">
+                <a:solidFill>
+                  <a:srgbClr val="E9C46A"/>
+                </a:solidFill>
+                <a:latin typeface="Calibri" pitchFamily="34" charset="0"/>
+                <a:ea typeface="Calibri" pitchFamily="34" charset="-122"/>
+                <a:cs typeface="Calibri" pitchFamily="34" charset="-120"/>
+              </a:rPr>
+              <a:t>Dinámica</a:t>
+            </a:r>
+            <a:endParaRPr lang="en-US" sz="1000" dirty="0"/>
+          </a:p>
+        </p:txBody>
+      </p:sp>
+      <p:sp>
+        <p:nvSpPr>
+          <p:cNvPr id="31" name="Text 29"/>
+          <p:cNvSpPr/>
+          <p:nvPr/>
+        </p:nvSpPr>
+        <p:spPr>
+          <a:xfrm>
+            <a:off x="6309360" y="4297680"/>
+            <a:ext cx="5394960" cy="329184"/>
+          </a:xfrm>
+          <a:prstGeom prst="rect">
+            <a:avLst/>
+          </a:prstGeom>
+          <a:noFill/>
+          <a:ln/>
+        </p:spPr>
+        <p:txBody>
+          <a:bodyPr wrap="square" rtlCol="0" anchor="ctr"/>
+          <a:lstStyle/>
+          <a:p>
+            <a:pPr indent="0" marL="0">
+              <a:buNone/>
+            </a:pPr>
+            <a:r>
+              <a:rPr lang="en-US" sz="950" dirty="0">
+                <a:solidFill>
+                  <a:srgbClr val="F4DAD5"/>
+                </a:solidFill>
+                <a:latin typeface="Calibri" pitchFamily="34" charset="0"/>
+                <a:ea typeface="Calibri" pitchFamily="34" charset="-122"/>
+                <a:cs typeface="Calibri" pitchFamily="34" charset="-120"/>
+              </a:rPr>
+              <a:t>Puede evolucionar — momentos más densos, silencios, variación. Es una composición</a:t>
+            </a:r>
+            <a:endParaRPr lang="en-US" sz="950" dirty="0"/>
+          </a:p>
+        </p:txBody>
+      </p:sp>
+      <p:sp>
+        <p:nvSpPr>
+          <p:cNvPr id="32" name="Text 30"/>
+          <p:cNvSpPr/>
+          <p:nvPr/>
+        </p:nvSpPr>
+        <p:spPr>
+          <a:xfrm>
+            <a:off x="6309360" y="4718304"/>
+            <a:ext cx="1920240" cy="274320"/>
+          </a:xfrm>
+          <a:prstGeom prst="rect">
+            <a:avLst/>
+          </a:prstGeom>
+          <a:noFill/>
+          <a:ln/>
+        </p:spPr>
+        <p:txBody>
+          <a:bodyPr wrap="square" rtlCol="0" anchor="ctr"/>
+          <a:lstStyle/>
+          <a:p>
+            <a:pPr indent="0" marL="0">
+              <a:buNone/>
+            </a:pPr>
+            <a:r>
+              <a:rPr lang="en-US" sz="1000" b="1" dirty="0">
+                <a:solidFill>
+                  <a:srgbClr val="E9C46A"/>
+                </a:solidFill>
+                <a:latin typeface="Calibri" pitchFamily="34" charset="0"/>
+                <a:ea typeface="Calibri" pitchFamily="34" charset="-122"/>
+                <a:cs typeface="Calibri" pitchFamily="34" charset="-120"/>
+              </a:rPr>
+              <a:t>EQ / Reverb</a:t>
+            </a:r>
+            <a:endParaRPr lang="en-US" sz="1000" dirty="0"/>
+          </a:p>
+        </p:txBody>
+      </p:sp>
+      <p:sp>
+        <p:nvSpPr>
+          <p:cNvPr id="33" name="Text 31"/>
+          <p:cNvSpPr/>
+          <p:nvPr/>
+        </p:nvSpPr>
+        <p:spPr>
+          <a:xfrm>
+            <a:off x="6309360" y="4956048"/>
+            <a:ext cx="5394960" cy="329184"/>
+          </a:xfrm>
+          <a:prstGeom prst="rect">
+            <a:avLst/>
+          </a:prstGeom>
+          <a:noFill/>
+          <a:ln/>
+        </p:spPr>
+        <p:txBody>
+          <a:bodyPr wrap="square" rtlCol="0" anchor="ctr"/>
+          <a:lstStyle/>
+          <a:p>
+            <a:pPr indent="0" marL="0">
+              <a:buNone/>
+            </a:pPr>
+            <a:r>
+              <a:rPr lang="en-US" sz="950" dirty="0">
+                <a:solidFill>
+                  <a:srgbClr val="F4DAD5"/>
+                </a:solidFill>
+                <a:latin typeface="Calibri" pitchFamily="34" charset="0"/>
+                <a:ea typeface="Calibri" pitchFamily="34" charset="-122"/>
+                <a:cs typeface="Calibri" pitchFamily="34" charset="-120"/>
+              </a:rPr>
+              <a:t>EQ global de la mezcla terminada. Verificar mono-compatibility del resultado final</a:t>
+            </a:r>
+            <a:endParaRPr lang="en-US" sz="950" dirty="0"/>
+          </a:p>
+        </p:txBody>
+      </p:sp>
+      <p:sp>
+        <p:nvSpPr>
+          <p:cNvPr id="34" name="Shape 32"/>
+          <p:cNvSpPr/>
+          <p:nvPr/>
+        </p:nvSpPr>
+        <p:spPr>
+          <a:xfrm>
+            <a:off x="0" y="6720840"/>
+            <a:ext cx="12192000" cy="137160"/>
+          </a:xfrm>
+          <a:prstGeom prst="rect">
+            <a:avLst/>
+          </a:prstGeom>
+          <a:solidFill>
+            <a:srgbClr val="4A0C0C"/>
+          </a:solidFill>
+          <a:ln w="12700">
+            <a:solidFill>
+              <a:srgbClr val="4A0C0C"/>
+            </a:solidFill>
+            <a:prstDash val="solid"/>
+          </a:ln>
+        </p:spPr>
+      </p:sp>
+      <p:sp>
+        <p:nvSpPr>
+          <p:cNvPr id="35" name="Text 33"/>
+          <p:cNvSpPr/>
+          <p:nvPr/>
+        </p:nvSpPr>
+        <p:spPr>
+          <a:xfrm>
+            <a:off x="274320" y="6675120"/>
+            <a:ext cx="5486400" cy="182880"/>
+          </a:xfrm>
+          <a:prstGeom prst="rect">
+            <a:avLst/>
+          </a:prstGeom>
+          <a:noFill/>
+          <a:ln/>
+        </p:spPr>
+        <p:txBody>
+          <a:bodyPr wrap="square" rtlCol="0" anchor="ctr"/>
+          <a:lstStyle/>
+          <a:p>
+            <a:pPr indent="0" marL="0">
+              <a:buNone/>
+            </a:pPr>
+            <a:r>
+              <a:rPr lang="en-US" sz="800" i="1" dirty="0">
+                <a:solidFill>
+                  <a:srgbClr val="B89B96"/>
+                </a:solidFill>
+                <a:latin typeface="Calibri" pitchFamily="34" charset="0"/>
+                <a:ea typeface="Calibri" pitchFamily="34" charset="-122"/>
+                <a:cs typeface="Calibri" pitchFamily="34" charset="-120"/>
+              </a:rPr>
+              <a:t>RESONANCIA — Casa del Cuenco</a:t>
+            </a:r>
+            <a:endParaRPr lang="en-US" sz="800" dirty="0"/>
+          </a:p>
+        </p:txBody>
+      </p:sp>
+      <p:sp>
+        <p:nvSpPr>
+          <p:cNvPr id="36" name="Text 34"/>
+          <p:cNvSpPr/>
+          <p:nvPr/>
+        </p:nvSpPr>
+        <p:spPr>
+          <a:xfrm>
+            <a:off x="11430000" y="6675120"/>
+            <a:ext cx="731520" cy="182880"/>
+          </a:xfrm>
+          <a:prstGeom prst="rect">
+            <a:avLst/>
+          </a:prstGeom>
+          <a:noFill/>
+          <a:ln/>
+        </p:spPr>
+        <p:txBody>
+          <a:bodyPr wrap="square" rtlCol="0" anchor="ctr"/>
+          <a:lstStyle/>
+          <a:p>
+            <a:pPr algn="r" indent="0" marL="0">
+              <a:buNone/>
+            </a:pPr>
+            <a:r>
+              <a:rPr lang="en-US" sz="800" dirty="0">
+                <a:solidFill>
+                  <a:srgbClr val="B89B96"/>
+                </a:solidFill>
+                <a:latin typeface="Calibri" pitchFamily="34" charset="0"/>
+                <a:ea typeface="Calibri" pitchFamily="34" charset="-122"/>
+                <a:cs typeface="Calibri" pitchFamily="34" charset="-120"/>
+              </a:rPr>
+              <a:t>3 / 3</a:t>
+            </a:r>
+            <a:endParaRPr lang="en-US" sz="800" dirty="0"/>
+          </a:p>
+        </p:txBody>
+      </p:sp>
+    </p:spTree>
+  </p:cSld>
+  <p:clrMapOvr>
+    <a:masterClrMapping/>
+  </p:clrMapOvr>
+</p:sld>
+</file>
+
 <file path=ppt/theme/theme1.xml><?xml version="1.0" encoding="utf-8"?>
 <a:theme xmlns:a="http://schemas.openxmlformats.org/drawingml/2006/main" name="Office Theme">
   <a:themeElements>

</xml_diff>